<commit_message>
Zet het logo van Mannen van 80 op de cover
Hun logo is wit op een groene tegel, dus die tegel wordt zelf de
chip in plaats van een groen vlak in een cremekleurig vlak. Een
logo met eigen achtergrondkleur staat nu op volle hoogte naast
het LINK.-logo, in zowel de PDF als de PowerPoint.

Co-Authored-By: Claude Opus 5 <noreply@anthropic.com>
Claude-Session: https://claude.ai/code/session_0141FN3f3hHkYQHTyvTJJGrw
</commit_message>
<xml_diff>
--- a/output/LINK. kennismaking Mannen van 80.pptx
+++ b/output/LINK. kennismaking Mannen van 80.pptx
@@ -2617,67 +2617,30 @@
           </a:p>
         </p:txBody>
       </p:sp>
-      <p:sp>
-        <p:nvSpPr>
-          <p:cNvPr id="32" name="Shape 30"/>
-          <p:cNvSpPr/>
-          <p:nvPr/>
-        </p:nvSpPr>
-        <p:spPr>
-          <a:xfrm>
-            <a:off x="1854195" y="5714986"/>
-            <a:ext cx="1396997" cy="406399"/>
-          </a:xfrm>
-          <a:prstGeom prst="roundRect">
-            <a:avLst>
-              <a:gd name="adj" fmla="val 21875"/>
-            </a:avLst>
-          </a:prstGeom>
-          <a:solidFill>
-            <a:srgbClr val="F8F4EB"/>
-          </a:solidFill>
-          <a:ln/>
-        </p:spPr>
-      </p:sp>
-      <p:sp>
-        <p:nvSpPr>
-          <p:cNvPr id="33" name="Text 31"/>
-          <p:cNvSpPr txBox="1"/>
-          <p:nvPr/>
-        </p:nvSpPr>
-        <p:spPr>
-          <a:xfrm>
-            <a:off x="1854195" y="5714986"/>
-            <a:ext cx="1396997" cy="406399"/>
-          </a:xfrm>
-          <a:prstGeom prst="rect">
-            <a:avLst/>
-          </a:prstGeom>
-          <a:noFill/>
-          <a:ln/>
-        </p:spPr>
-        <p:txBody>
-          <a:bodyPr wrap="square" lIns="0" tIns="0" rIns="0" bIns="0" rtlCol="0" anchor="ctr"/>
-          <a:lstStyle/>
-          <a:p>
-            <a:pPr algn="ctr" indent="0" marL="0">
-              <a:buNone/>
-            </a:pPr>
-            <a:r>
-              <a:rPr lang="en-US" sz="1500" b="1" dirty="0">
-                <a:solidFill>
-                  <a:srgbClr val="1C2230"/>
-                </a:solidFill>
-                <a:latin typeface="Arial" pitchFamily="34" charset="0"/>
-                <a:ea typeface="Arial" pitchFamily="34" charset="-122"/>
-                <a:cs typeface="Arial" pitchFamily="34" charset="-120"/>
-              </a:rPr>
-              <a:t>Mannen van 80</a:t>
-            </a:r>
-            <a:endParaRPr lang="en-US" sz="1500" dirty="0"/>
-          </a:p>
-        </p:txBody>
-      </p:sp>
+      <p:pic>
+        <p:nvPicPr>
+          <p:cNvPr id="32" name="Image 0" descr="preencoded.png">    </p:cNvPr>
+          <p:cNvPicPr>
+            <a:picLocks noChangeAspect="1"/>
+          </p:cNvPicPr>
+          <p:nvPr/>
+        </p:nvPicPr>
+        <p:blipFill>
+          <a:blip r:embed="rId1"/>
+          <a:stretch>
+            <a:fillRect/>
+          </a:stretch>
+        </p:blipFill>
+        <p:spPr>
+          <a:xfrm>
+            <a:off x="1854195" y="5702286"/>
+            <a:ext cx="887887" cy="431799"/>
+          </a:xfrm>
+          <a:prstGeom prst="rect">
+            <a:avLst/>
+          </a:prstGeom>
+        </p:spPr>
+      </p:pic>
     </p:spTree>
   </p:cSld>
   <p:clrMapOvr>

</xml_diff>

<commit_message>
Geen belscripts: USP's vastleggen in plaats van een script schrijven
LINK werkt niet met belscripts. Overal waar belscript stond gaat het nu
over de USP's en de opbouw van het gesprek die we samen vastleggen en
die de klant goedkeurt. Doorgevoerd in alle twintig contentbestanden en
alle decks opnieuw gebouwd.

In het pilotvoorstel voor OK Creative Agency staat het ook expliciet als
onderscheid: geen afgelezen belscript, maar vastgelegde USP's en een
echt gesprek.

Co-Authored-By: Claude Opus 5 <noreply@anthropic.com>
Claude-Session: https://claude.ai/code/session_0141FN3f3hHkYQHTyvTJJGrw
</commit_message>
<xml_diff>
--- a/output/LINK. kennismaking Mannen van 80.pptx
+++ b/output/LINK. kennismaking Mannen van 80.pptx
@@ -4046,7 +4046,7 @@
                 <a:ea typeface="Arial" pitchFamily="34" charset="-122"/>
                 <a:cs typeface="Arial" pitchFamily="34" charset="-120"/>
               </a:rPr>
-              <a:t>Eén persoon die jullie campagne kent, van script tot rapportage.</a:t>
+              <a:t>Eén persoon die jullie campagne kent, van kick-off tot rapportage.</a:t>
             </a:r>
             <a:endParaRPr lang="en-US" sz="950" dirty="0"/>
           </a:p>
@@ -5519,7 +5519,7 @@
                 <a:ea typeface="Arial" pitchFamily="34" charset="-122"/>
                 <a:cs typeface="Arial" pitchFamily="34" charset="-120"/>
               </a:rPr>
-              <a:t>Samen scherp: doelgroep, beslisser, propositie, bezwaren en wat een goede afspraak voor jullie is. Wij schrijven het belscript, jullie keuren goed.</a:t>
+              <a:t>Samen scherp: doelgroep, beslisser, propositie, bezwaren en wat een goede afspraak voor jullie is. Wij leggen de USP's en de opbouw van het gesprek vast, jullie keuren goed.</a:t>
             </a:r>
             <a:endParaRPr lang="en-US" sz="900" dirty="0"/>
           </a:p>
@@ -7505,7 +7505,7 @@
                 <a:ea typeface="Arial" pitchFamily="34" charset="-122"/>
                 <a:cs typeface="Arial" pitchFamily="34" charset="-120"/>
               </a:rPr>
-              <a:t>Kick-off en belscript</a:t>
+              <a:t>Kick-off en USP's</a:t>
             </a:r>
             <a:endParaRPr lang="en-US" sz="1150" dirty="0"/>
           </a:p>
@@ -7547,7 +7547,7 @@
                 <a:ea typeface="Arial" pitchFamily="34" charset="-122"/>
                 <a:cs typeface="Arial" pitchFamily="34" charset="-120"/>
               </a:rPr>
-              <a:t>Samen scherp wat we gaan vertellen en bij wie. Wij schrijven het belscript, jullie keuren het goed.</a:t>
+              <a:t>Samen scherp wat we gaan vertellen en bij wie. Wij leggen de USP's vast, jullie keuren ze goed.</a:t>
             </a:r>
             <a:endParaRPr lang="en-US" sz="875" dirty="0"/>
           </a:p>
@@ -8266,7 +8266,7 @@
         <p:spPr>
           <a:xfrm>
             <a:off x="3733791" y="5245087"/>
-            <a:ext cx="3555991" cy="215899"/>
+            <a:ext cx="3746491" cy="215899"/>
           </a:xfrm>
           <a:prstGeom prst="rect">
             <a:avLst/>
@@ -8290,7 +8290,7 @@
                 <a:ea typeface="Arial" pitchFamily="34" charset="-122"/>
                 <a:cs typeface="Arial" pitchFamily="34" charset="-120"/>
               </a:rPr>
-              <a:t>Kick-off en belscript</a:t>
+              <a:t>Kick-off en USP's</a:t>
             </a:r>
             <a:endParaRPr lang="en-US" sz="900" dirty="0"/>
           </a:p>
@@ -8312,7 +8312,7 @@
         </p:blipFill>
         <p:spPr>
           <a:xfrm>
-            <a:off x="7340582" y="5276837"/>
+            <a:off x="7556481" y="5276837"/>
             <a:ext cx="127000" cy="127000"/>
           </a:xfrm>
           <a:prstGeom prst="rect">
@@ -8328,8 +8328,8 @@
         </p:nvSpPr>
         <p:spPr>
           <a:xfrm>
-            <a:off x="7543781" y="5245087"/>
-            <a:ext cx="3555991" cy="215899"/>
+            <a:off x="7759681" y="5245087"/>
+            <a:ext cx="3746491" cy="215899"/>
           </a:xfrm>
           <a:prstGeom prst="rect">
             <a:avLst/>
@@ -8392,7 +8392,7 @@
         <p:spPr>
           <a:xfrm>
             <a:off x="3733791" y="5499086"/>
-            <a:ext cx="3555991" cy="215899"/>
+            <a:ext cx="3746491" cy="215899"/>
           </a:xfrm>
           <a:prstGeom prst="rect">
             <a:avLst/>
@@ -8438,7 +8438,7 @@
         </p:blipFill>
         <p:spPr>
           <a:xfrm>
-            <a:off x="7340582" y="5530836"/>
+            <a:off x="7556481" y="5530836"/>
             <a:ext cx="127000" cy="127000"/>
           </a:xfrm>
           <a:prstGeom prst="rect">
@@ -8454,8 +8454,8 @@
         </p:nvSpPr>
         <p:spPr>
           <a:xfrm>
-            <a:off x="7543781" y="5499086"/>
-            <a:ext cx="3555991" cy="215899"/>
+            <a:off x="7759681" y="5499086"/>
+            <a:ext cx="3746491" cy="215899"/>
           </a:xfrm>
           <a:prstGeom prst="rect">
             <a:avLst/>
@@ -8518,7 +8518,7 @@
         <p:spPr>
           <a:xfrm>
             <a:off x="3733791" y="5753086"/>
-            <a:ext cx="3555991" cy="215899"/>
+            <a:ext cx="3746491" cy="215899"/>
           </a:xfrm>
           <a:prstGeom prst="rect">
             <a:avLst/>
@@ -8564,7 +8564,7 @@
         </p:blipFill>
         <p:spPr>
           <a:xfrm>
-            <a:off x="7340582" y="5784836"/>
+            <a:off x="7556481" y="5784836"/>
             <a:ext cx="127000" cy="127000"/>
           </a:xfrm>
           <a:prstGeom prst="rect">
@@ -8580,8 +8580,8 @@
         </p:nvSpPr>
         <p:spPr>
           <a:xfrm>
-            <a:off x="7543781" y="5753086"/>
-            <a:ext cx="3555991" cy="215899"/>
+            <a:off x="7759681" y="5753086"/>
+            <a:ext cx="3746491" cy="215899"/>
           </a:xfrm>
           <a:prstGeom prst="rect">
             <a:avLst/>
@@ -10313,7 +10313,7 @@
                 <a:ea typeface="Arial" pitchFamily="34" charset="-122"/>
                 <a:cs typeface="Arial" pitchFamily="34" charset="-120"/>
               </a:rPr>
-              <a:t>Goedkeuring belscript</a:t>
+              <a:t>Goedkeuring op de USP's</a:t>
             </a:r>
             <a:endParaRPr lang="en-US" sz="1450" dirty="0"/>
           </a:p>

</xml_diff>